<commit_message>
Clear post-wave leftovers: email asks, branding, markup, legend
After-the-wave leftovers from the three-surfaces review: IC Stage 2
markup as a question; BUS-313 grades defer to grading-scale.md; every
student-facing @hawaii.edu ask replaced (Adam 2026-10-05, no UH Claude
license); branding binaries to #024731 with an instructor footer;
workbook Cover named-range text fixed; sample AGENTS.md legend matches
the house standard. DIG-15.

Co-Authored-By: Claude Fable 5.1 <noreply@anthropic.com>
</commit_message>
<xml_diff>
--- a/docs/_branding/templates/shidler-finance-light.pptx
+++ b/docs/_branding/templates/shidler-finance-light.pptx
@@ -3044,7 +3044,7 @@
             <a:avLst/>
           </a:prstGeom>
           <a:solidFill>
-            <a:srgbClr val="1B5E40"/>
+            <a:srgbClr val="024731"/>
           </a:solidFill>
           <a:ln w="0">
             <a:noFill/>
@@ -3332,12 +3332,12 @@
           <a:gradFill>
             <a:gsLst>
               <a:gs pos="0">
-                <a:srgbClr val="1B5E40">
+                <a:srgbClr val="024731">
                   <a:alpha val="55000"/>
                 </a:srgbClr>
               </a:gs>
               <a:gs pos="100000">
-                <a:srgbClr val="1B5E40">
+                <a:srgbClr val="024731">
                   <a:alpha val="8000"/>
                 </a:srgbClr>
               </a:gs>
@@ -3373,7 +3373,7 @@
             <a:avLst/>
           </a:prstGeom>
           <a:solidFill>
-            <a:srgbClr val="1B5E40">
+            <a:srgbClr val="024731">
               <a:alpha val="50000"/>
             </a:srgbClr>
           </a:solidFill>
@@ -3828,7 +3828,7 @@
             <a:avLst/>
           </a:prstGeom>
           <a:solidFill>
-            <a:srgbClr val="1B5E40"/>
+            <a:srgbClr val="024731"/>
           </a:solidFill>
           <a:ln w="0">
             <a:noFill/>
@@ -3897,7 +3897,7 @@
                 </a:solidFill>
                 <a:latin typeface="Source Sans Pro"/>
               </a:rPr>
-              <a:t>Semester Year  •  Department of Finance</a:t>
+              <a:t>Semester Year</a:t>
             </a:r>
           </a:p>
         </p:txBody>
@@ -3979,7 +3979,7 @@
                 </a:solidFill>
                 <a:latin typeface="Source Sans Pro"/>
               </a:rPr>
-              <a:t>University of Hawaiʻi at Mānoa  •  Shidler College of Business</a:t>
+              <a:t>Adam W. Stauffer</a:t>
             </a:r>
           </a:p>
         </p:txBody>
@@ -4493,7 +4493,7 @@
             <a:avLst/>
           </a:prstGeom>
           <a:solidFill>
-            <a:srgbClr val="1B5E40"/>
+            <a:srgbClr val="024731"/>
           </a:solidFill>
           <a:ln w="0">
             <a:noFill/>
@@ -4817,7 +4817,7 @@
             <a:avLst/>
           </a:prstGeom>
           <a:solidFill>
-            <a:srgbClr val="1B5E40"/>
+            <a:srgbClr val="024731"/>
           </a:solidFill>
           <a:ln w="0">
             <a:noFill/>
@@ -4846,7 +4846,7 @@
             <a:avLst/>
           </a:prstGeom>
           <a:solidFill>
-            <a:srgbClr val="1B5E40"/>
+            <a:srgbClr val="024731"/>
           </a:solidFill>
           <a:ln w="0">
             <a:noFill/>
@@ -4941,7 +4941,7 @@
         <a:srgbClr val="E2E8F0"/>
       </a:lt2>
       <a:accent1>
-        <a:srgbClr val="1B5E40"/>
+        <a:srgbClr val="024731"/>
       </a:accent1>
       <a:accent2>
         <a:srgbClr val="8A6F3A"/>

</xml_diff>